<commit_message>
fix: titre mémo sur une seule ligne (textbox pleine largeur + 18pt)
Textbox titre élargie à CW=18.03cm (au lieu de 14.05) et taille réduite
de 20 à 18pt pour garantir une seule ligne même pour les titres longs.

Co-Authored-By: Claude Sonnet 4.6 <noreply@anthropic.com>
</commit_message>
<xml_diff>
--- a/assets/memos/A1-memo.pptx
+++ b/assets/memos/A1-memo.pptx
@@ -3105,8 +3105,8 @@
         </p:nvSpPr>
         <p:spPr>
           <a:xfrm>
-            <a:off x="648000" y="1180800"/>
-            <a:ext cx="5058000" cy="511200"/>
+            <a:off x="532800" y="1180800"/>
+            <a:ext cx="6490800" cy="511200"/>
           </a:xfrm>
           <a:prstGeom prst="rect">
             <a:avLst/>
@@ -3128,7 +3128,7 @@
               </a:spcAft>
             </a:pPr>
             <a:r>
-              <a:rPr sz="2000" b="1" i="0">
+              <a:rPr sz="1800" b="1" i="0">
                 <a:solidFill>
                   <a:srgbClr val="4388BC"/>
                 </a:solidFill>
@@ -4562,8 +4562,8 @@
         </p:nvSpPr>
         <p:spPr>
           <a:xfrm>
-            <a:off x="648000" y="1180800"/>
-            <a:ext cx="5058000" cy="511200"/>
+            <a:off x="532800" y="1180800"/>
+            <a:ext cx="6490800" cy="511200"/>
           </a:xfrm>
           <a:prstGeom prst="rect">
             <a:avLst/>
@@ -4585,7 +4585,7 @@
               </a:spcAft>
             </a:pPr>
             <a:r>
-              <a:rPr sz="2000" b="1" i="0">
+              <a:rPr sz="1800" b="1" i="0">
                 <a:solidFill>
                   <a:srgbClr val="4388BC"/>
                 </a:solidFill>

</xml_diff>

<commit_message>
fix: suppression de la troncature des bullets et titres dans les mémos
Les textbox ont word_wrap=True — le trunc(t, 65/45/50) coupait
inutilement le texte avec "…". Supprimé sur les bullets, titres
d'étape et titres BSA.

Co-Authored-By: Claude Sonnet 4.6 <noreply@anthropic.com>
</commit_message>
<xml_diff>
--- a/assets/memos/A1-memo.pptx
+++ b/assets/memos/A1-memo.pptx
@@ -3402,7 +3402,7 @@
                 </a:solidFill>
                 <a:latin typeface="Arial"/>
               </a:rPr>
-              <a:t>→ Un ordinateur est une machine qui vous permet d'écrire, de commun…</a:t>
+              <a:t>→ Un ordinateur est une machine qui vous permet d'écrire, de communiquer, de chercher des informations et bien plus encore. Il en existe plusieurs formes selon vos besoins.</a:t>
             </a:r>
           </a:p>
           <a:p>
@@ -3440,7 +3440,7 @@
                 </a:solidFill>
                 <a:latin typeface="Arial"/>
               </a:rPr>
-              <a:t>→ Fixe, puissant, idéal à la maison. Composé d'une tour, d'un écran…</a:t>
+              <a:t>→ Fixe, puissant, idéal à la maison. Composé d'une tour, d'un écran, d'un clavier et d'une souris séparés.</a:t>
             </a:r>
           </a:p>
           <a:p>
@@ -3708,7 +3708,7 @@
                 </a:solidFill>
                 <a:latin typeface="Arial"/>
               </a:rPr>
-              <a:t>→ Chaque composant a un rôle précis. Apprenez à les reconnaître pou…</a:t>
+              <a:t>→ Chaque composant a un rôle précis. Apprenez à les reconnaître pour mieux les utiliser.</a:t>
             </a:r>
           </a:p>
           <a:p>
@@ -3727,7 +3727,7 @@
                 </a:solidFill>
                 <a:latin typeface="Arial"/>
               </a:rPr>
-              <a:t>→ Affiche tout ce qui se passe — c'est votre fenêtre sur l'ordinate…</a:t>
+              <a:t>→ Affiche tout ce qui se passe — c'est votre fenêtre sur l'ordinateur.</a:t>
             </a:r>
           </a:p>
           <a:p>
@@ -4014,7 +4014,7 @@
                 </a:solidFill>
                 <a:latin typeface="Arial"/>
               </a:rPr>
-              <a:t>→ Ces gestes simples protègent votre ordinateur et évitent les pert…</a:t>
+              <a:t>→ Ces gestes simples protègent votre ordinateur et évitent les pertes de données. À pratiquer dès le premier jour !</a:t>
             </a:r>
           </a:p>
           <a:p>
@@ -4320,7 +4320,7 @@
                 </a:solidFill>
                 <a:latin typeface="Arial"/>
               </a:rPr>
-              <a:t>→ Le bureau, c'est votre espace de travail principal. Trois zones e…</a:t>
+              <a:t>→ Le bureau, c'est votre espace de travail principal. Trois zones essentielles à repérer dès le départ.</a:t>
             </a:r>
           </a:p>
           <a:p>
@@ -4358,7 +4358,7 @@
                 </a:solidFill>
                 <a:latin typeface="Arial"/>
               </a:rPr>
-              <a:t>→ Petites images sur le bureau qui représentent vos programmes et f…</a:t>
+              <a:t>→ Petites images sur le bureau qui représentent vos programmes et fichiers. Double-cliquez pour les ouvrir.</a:t>
             </a:r>
           </a:p>
           <a:p>
@@ -4859,7 +4859,7 @@
                 </a:solidFill>
                 <a:latin typeface="Arial"/>
               </a:rPr>
-              <a:t>→ La souris vous permet d'interagir avec tout ce qui est à l'écran.…</a:t>
+              <a:t>→ La souris vous permet d'interagir avec tout ce qui est à l'écran. Prenez le temps de bien la tenir, et entraînez-vous à ces quatre gestes fondamentaux.</a:t>
             </a:r>
           </a:p>
           <a:p>
@@ -5165,7 +5165,7 @@
                 </a:solidFill>
                 <a:latin typeface="Arial"/>
               </a:rPr>
-              <a:t>→ Pas besoin de connaître toutes les touches ! Voici les indispensa…</a:t>
+              <a:t>→ Pas besoin de connaître toutes les touches ! Voici les indispensables pour écrire et naviguer confortablement.</a:t>
             </a:r>
           </a:p>
           <a:p>
@@ -5203,7 +5203,7 @@
                 </a:solidFill>
                 <a:latin typeface="Arial"/>
               </a:rPr>
-              <a:t>→ Effacez une lettre mal tapée. Retour arrière supprime à gauche du…</a:t>
+              <a:t>→ Effacez une lettre mal tapée. Retour arrière supprime à gauche du curseur, Suppr à droite.</a:t>
             </a:r>
           </a:p>
           <a:p>
@@ -5222,7 +5222,7 @@
                 </a:solidFill>
                 <a:latin typeface="Arial"/>
               </a:rPr>
-              <a:t>→ Valide une action ou passe à la ligne. La touche la plus utilisée…</a:t>
+              <a:t>→ Valide une action ou passe à la ligne. La touche la plus utilisée !</a:t>
             </a:r>
           </a:p>
         </p:txBody>
@@ -5471,7 +5471,7 @@
                 </a:solidFill>
                 <a:latin typeface="Arial"/>
               </a:rPr>
-              <a:t>→ Chaque programme s'ouvre dans une fenêtre. Trois petits boutons e…</a:t>
+              <a:t>→ Chaque programme s'ouvre dans une fenêtre. Trois petits boutons en haut à droite vous permettent de tout contrôler.</a:t>
             </a:r>
           </a:p>
           <a:p>
@@ -5490,7 +5490,7 @@
                 </a:solidFill>
                 <a:latin typeface="Arial"/>
               </a:rPr>
-              <a:t>→ La fenêtre disparaît de l'écran mais reste accessible dans la bar…</a:t>
+              <a:t>→ La fenêtre disparaît de l'écran mais reste accessible dans la barre des tâches.</a:t>
             </a:r>
           </a:p>
           <a:p>

</xml_diff>

<commit_message>
fix: hauteur dynamique des blocs step dans les mémos
calc_step_h() estime le nombre de lignes wrappées (78 chars/ligne,
0.42 cm/ligne) et ajuste la hauteur du bloc pour inclure une marge
basse. Le découpage page1/page2 est aussi basé sur la hauteur réelle
plutôt qu'un nombre fixe de 4 étapes.

Co-Authored-By: Claude Sonnet 4.6 <noreply@anthropic.com>
</commit_message>
<xml_diff>
--- a/assets/memos/A1-memo.pptx
+++ b/assets/memos/A1-memo.pptx
@@ -3167,7 +3167,7 @@
         <p:spPr>
           <a:xfrm>
             <a:off x="532800" y="1749600"/>
-            <a:ext cx="6490800" cy="1371600"/>
+            <a:ext cx="6490800" cy="1684800"/>
           </a:xfrm>
           <a:prstGeom prst="rect">
             <a:avLst/>
@@ -3208,7 +3208,7 @@
         <p:spPr>
           <a:xfrm>
             <a:off x="532800" y="1749600"/>
-            <a:ext cx="572400" cy="1371600"/>
+            <a:ext cx="572400" cy="1684800"/>
           </a:xfrm>
           <a:prstGeom prst="rect">
             <a:avLst/>
@@ -3374,7 +3374,7 @@
         <p:spPr>
           <a:xfrm>
             <a:off x="1159200" y="2214000"/>
-            <a:ext cx="5828400" cy="885600"/>
+            <a:ext cx="5828400" cy="1184399"/>
           </a:xfrm>
           <a:prstGeom prst="rect">
             <a:avLst/>
@@ -3472,8 +3472,8 @@
         </p:nvSpPr>
         <p:spPr>
           <a:xfrm>
-            <a:off x="532800" y="3186000"/>
-            <a:ext cx="6490800" cy="1371600"/>
+            <a:off x="532800" y="3499199"/>
+            <a:ext cx="6490800" cy="1382400"/>
           </a:xfrm>
           <a:prstGeom prst="rect">
             <a:avLst/>
@@ -3513,8 +3513,8 @@
         </p:nvSpPr>
         <p:spPr>
           <a:xfrm>
-            <a:off x="532800" y="3186000"/>
-            <a:ext cx="572400" cy="1371600"/>
+            <a:off x="532800" y="3499199"/>
+            <a:ext cx="572400" cy="1382400"/>
           </a:xfrm>
           <a:prstGeom prst="rect">
             <a:avLst/>
@@ -3554,7 +3554,7 @@
         </p:nvSpPr>
         <p:spPr>
           <a:xfrm>
-            <a:off x="1206000" y="3607200"/>
+            <a:off x="1206000" y="3920399"/>
             <a:ext cx="5752800" cy="7200"/>
           </a:xfrm>
           <a:prstGeom prst="rect">
@@ -3595,7 +3595,7 @@
         </p:nvSpPr>
         <p:spPr>
           <a:xfrm>
-            <a:off x="532800" y="3252600"/>
+            <a:off x="532800" y="3565800"/>
             <a:ext cx="572400" cy="288000"/>
           </a:xfrm>
           <a:prstGeom prst="rect">
@@ -3637,7 +3637,7 @@
         </p:nvSpPr>
         <p:spPr>
           <a:xfrm>
-            <a:off x="1177200" y="3221999"/>
+            <a:off x="1177200" y="3535199"/>
             <a:ext cx="5810400" cy="370799"/>
           </a:xfrm>
           <a:prstGeom prst="rect">
@@ -3679,8 +3679,8 @@
         </p:nvSpPr>
         <p:spPr>
           <a:xfrm>
-            <a:off x="1159200" y="3650399"/>
-            <a:ext cx="5828400" cy="885600"/>
+            <a:off x="1159200" y="3963599"/>
+            <a:ext cx="5828400" cy="881999"/>
           </a:xfrm>
           <a:prstGeom prst="rect">
             <a:avLst/>
@@ -3778,8 +3778,8 @@
         </p:nvSpPr>
         <p:spPr>
           <a:xfrm>
-            <a:off x="532800" y="4622400"/>
-            <a:ext cx="6490800" cy="1371600"/>
+            <a:off x="532800" y="4946399"/>
+            <a:ext cx="6490800" cy="1382400"/>
           </a:xfrm>
           <a:prstGeom prst="rect">
             <a:avLst/>
@@ -3819,8 +3819,8 @@
         </p:nvSpPr>
         <p:spPr>
           <a:xfrm>
-            <a:off x="532800" y="4622400"/>
-            <a:ext cx="572400" cy="1371600"/>
+            <a:off x="532800" y="4946399"/>
+            <a:ext cx="572400" cy="1382400"/>
           </a:xfrm>
           <a:prstGeom prst="rect">
             <a:avLst/>
@@ -3860,7 +3860,7 @@
         </p:nvSpPr>
         <p:spPr>
           <a:xfrm>
-            <a:off x="1206000" y="5043600"/>
+            <a:off x="1206000" y="5367599"/>
             <a:ext cx="5752800" cy="7200"/>
           </a:xfrm>
           <a:prstGeom prst="rect">
@@ -3901,7 +3901,7 @@
         </p:nvSpPr>
         <p:spPr>
           <a:xfrm>
-            <a:off x="532800" y="4689000"/>
+            <a:off x="532800" y="5013000"/>
             <a:ext cx="572400" cy="288000"/>
           </a:xfrm>
           <a:prstGeom prst="rect">
@@ -3943,7 +3943,7 @@
         </p:nvSpPr>
         <p:spPr>
           <a:xfrm>
-            <a:off x="1177200" y="4658400"/>
+            <a:off x="1177200" y="4982399"/>
             <a:ext cx="5810400" cy="370799"/>
           </a:xfrm>
           <a:prstGeom prst="rect">
@@ -3985,8 +3985,8 @@
         </p:nvSpPr>
         <p:spPr>
           <a:xfrm>
-            <a:off x="1159200" y="5086800"/>
-            <a:ext cx="5828400" cy="885600"/>
+            <a:off x="1159200" y="5410799"/>
+            <a:ext cx="5828400" cy="881999"/>
           </a:xfrm>
           <a:prstGeom prst="rect">
             <a:avLst/>
@@ -4084,8 +4084,8 @@
         </p:nvSpPr>
         <p:spPr>
           <a:xfrm>
-            <a:off x="532800" y="6058799"/>
-            <a:ext cx="6490800" cy="1371600"/>
+            <a:off x="532800" y="6393599"/>
+            <a:ext cx="6490800" cy="1533600"/>
           </a:xfrm>
           <a:prstGeom prst="rect">
             <a:avLst/>
@@ -4125,8 +4125,8 @@
         </p:nvSpPr>
         <p:spPr>
           <a:xfrm>
-            <a:off x="532800" y="6058799"/>
-            <a:ext cx="572400" cy="1371600"/>
+            <a:off x="532800" y="6393599"/>
+            <a:ext cx="572400" cy="1533600"/>
           </a:xfrm>
           <a:prstGeom prst="rect">
             <a:avLst/>
@@ -4166,7 +4166,7 @@
         </p:nvSpPr>
         <p:spPr>
           <a:xfrm>
-            <a:off x="1206000" y="6480000"/>
+            <a:off x="1206000" y="6814800"/>
             <a:ext cx="5752800" cy="7200"/>
           </a:xfrm>
           <a:prstGeom prst="rect">
@@ -4207,7 +4207,7 @@
         </p:nvSpPr>
         <p:spPr>
           <a:xfrm>
-            <a:off x="532800" y="6125399"/>
+            <a:off x="532800" y="6460199"/>
             <a:ext cx="572400" cy="288000"/>
           </a:xfrm>
           <a:prstGeom prst="rect">
@@ -4249,7 +4249,7 @@
         </p:nvSpPr>
         <p:spPr>
           <a:xfrm>
-            <a:off x="1177200" y="6094800"/>
+            <a:off x="1177200" y="6429600"/>
             <a:ext cx="5810400" cy="370799"/>
           </a:xfrm>
           <a:prstGeom prst="rect">
@@ -4291,8 +4291,8 @@
         </p:nvSpPr>
         <p:spPr>
           <a:xfrm>
-            <a:off x="1159200" y="6523200"/>
-            <a:ext cx="5828400" cy="885600"/>
+            <a:off x="1159200" y="6858000"/>
+            <a:ext cx="5828400" cy="1033199"/>
           </a:xfrm>
           <a:prstGeom prst="rect">
             <a:avLst/>
@@ -4390,7 +4390,7 @@
         </p:nvSpPr>
         <p:spPr>
           <a:xfrm>
-            <a:off x="532800" y="7639200"/>
+            <a:off x="532800" y="8063999"/>
             <a:ext cx="6490800" cy="658800"/>
           </a:xfrm>
           <a:prstGeom prst="rect">
@@ -4433,7 +4433,7 @@
         </p:nvSpPr>
         <p:spPr>
           <a:xfrm>
-            <a:off x="1540799" y="7675200"/>
+            <a:off x="1540799" y="8099999"/>
             <a:ext cx="5410800" cy="604800"/>
           </a:xfrm>
           <a:prstGeom prst="rect">
@@ -4624,7 +4624,7 @@
         <p:spPr>
           <a:xfrm>
             <a:off x="532800" y="1749600"/>
-            <a:ext cx="6490800" cy="1371600"/>
+            <a:ext cx="6490800" cy="1382400"/>
           </a:xfrm>
           <a:prstGeom prst="rect">
             <a:avLst/>
@@ -4665,7 +4665,7 @@
         <p:spPr>
           <a:xfrm>
             <a:off x="532800" y="1749600"/>
-            <a:ext cx="572400" cy="1371600"/>
+            <a:ext cx="572400" cy="1382400"/>
           </a:xfrm>
           <a:prstGeom prst="rect">
             <a:avLst/>
@@ -4831,7 +4831,7 @@
         <p:spPr>
           <a:xfrm>
             <a:off x="1159200" y="2214000"/>
-            <a:ext cx="5828400" cy="885600"/>
+            <a:ext cx="5828400" cy="881999"/>
           </a:xfrm>
           <a:prstGeom prst="rect">
             <a:avLst/>
@@ -4929,8 +4929,8 @@
         </p:nvSpPr>
         <p:spPr>
           <a:xfrm>
-            <a:off x="532800" y="3186000"/>
-            <a:ext cx="6490800" cy="1371600"/>
+            <a:off x="532800" y="3196799"/>
+            <a:ext cx="6490800" cy="1533600"/>
           </a:xfrm>
           <a:prstGeom prst="rect">
             <a:avLst/>
@@ -4970,8 +4970,8 @@
         </p:nvSpPr>
         <p:spPr>
           <a:xfrm>
-            <a:off x="532800" y="3186000"/>
-            <a:ext cx="572400" cy="1371600"/>
+            <a:off x="532800" y="3196799"/>
+            <a:ext cx="572400" cy="1533600"/>
           </a:xfrm>
           <a:prstGeom prst="rect">
             <a:avLst/>
@@ -5011,7 +5011,7 @@
         </p:nvSpPr>
         <p:spPr>
           <a:xfrm>
-            <a:off x="1206000" y="3607200"/>
+            <a:off x="1206000" y="3617999"/>
             <a:ext cx="5752800" cy="7200"/>
           </a:xfrm>
           <a:prstGeom prst="rect">
@@ -5052,7 +5052,7 @@
         </p:nvSpPr>
         <p:spPr>
           <a:xfrm>
-            <a:off x="532800" y="3252600"/>
+            <a:off x="532800" y="3263400"/>
             <a:ext cx="572400" cy="288000"/>
           </a:xfrm>
           <a:prstGeom prst="rect">
@@ -5094,7 +5094,7 @@
         </p:nvSpPr>
         <p:spPr>
           <a:xfrm>
-            <a:off x="1177200" y="3221999"/>
+            <a:off x="1177200" y="3232799"/>
             <a:ext cx="5810400" cy="370799"/>
           </a:xfrm>
           <a:prstGeom prst="rect">
@@ -5136,8 +5136,8 @@
         </p:nvSpPr>
         <p:spPr>
           <a:xfrm>
-            <a:off x="1159200" y="3650399"/>
-            <a:ext cx="5828400" cy="885600"/>
+            <a:off x="1159200" y="3661199"/>
+            <a:ext cx="5828400" cy="1033199"/>
           </a:xfrm>
           <a:prstGeom prst="rect">
             <a:avLst/>
@@ -5235,8 +5235,8 @@
         </p:nvSpPr>
         <p:spPr>
           <a:xfrm>
-            <a:off x="532800" y="4622400"/>
-            <a:ext cx="6490800" cy="1371600"/>
+            <a:off x="532800" y="4795199"/>
+            <a:ext cx="6490800" cy="1533600"/>
           </a:xfrm>
           <a:prstGeom prst="rect">
             <a:avLst/>
@@ -5276,8 +5276,8 @@
         </p:nvSpPr>
         <p:spPr>
           <a:xfrm>
-            <a:off x="532800" y="4622400"/>
-            <a:ext cx="572400" cy="1371600"/>
+            <a:off x="532800" y="4795199"/>
+            <a:ext cx="572400" cy="1533600"/>
           </a:xfrm>
           <a:prstGeom prst="rect">
             <a:avLst/>
@@ -5317,7 +5317,7 @@
         </p:nvSpPr>
         <p:spPr>
           <a:xfrm>
-            <a:off x="1206000" y="5043600"/>
+            <a:off x="1206000" y="5216399"/>
             <a:ext cx="5752800" cy="7200"/>
           </a:xfrm>
           <a:prstGeom prst="rect">
@@ -5358,7 +5358,7 @@
         </p:nvSpPr>
         <p:spPr>
           <a:xfrm>
-            <a:off x="532800" y="4689000"/>
+            <a:off x="532800" y="4861800"/>
             <a:ext cx="572400" cy="288000"/>
           </a:xfrm>
           <a:prstGeom prst="rect">
@@ -5400,7 +5400,7 @@
         </p:nvSpPr>
         <p:spPr>
           <a:xfrm>
-            <a:off x="1177200" y="4658400"/>
+            <a:off x="1177200" y="4831199"/>
             <a:ext cx="5810400" cy="370799"/>
           </a:xfrm>
           <a:prstGeom prst="rect">
@@ -5442,8 +5442,8 @@
         </p:nvSpPr>
         <p:spPr>
           <a:xfrm>
-            <a:off x="1159200" y="5086800"/>
-            <a:ext cx="5828400" cy="885600"/>
+            <a:off x="1159200" y="5259599"/>
+            <a:ext cx="5828400" cy="1033199"/>
           </a:xfrm>
           <a:prstGeom prst="rect">
             <a:avLst/>

</xml_diff>